<commit_message>
Update PowerPoint for song #158 in FUBC - Українські
</commit_message>
<xml_diff>
--- a/fubc-ua/158-Слухайте вістку любові усі (Пісні Спасенних №156).pptx
+++ b/fubc-ua/158-Слухайте вістку любові усі (Пісні Спасенних №156).pptx
@@ -2028,7 +2028,7 @@
         </p:nvSpPr>
         <p:spPr>
           <a:xfrm>
-            <a:off x="2174291" y="1962912"/>
+            <a:off x="2273351" y="1962912"/>
             <a:ext cx="0" cy="594360"/>
           </a:xfrm>
           <a:prstGeom prst="line">
@@ -2051,7 +2051,7 @@
         </p:nvSpPr>
         <p:spPr>
           <a:xfrm>
-            <a:off x="10023805" y="1962912"/>
+            <a:off x="9924745" y="1962912"/>
             <a:ext cx="0" cy="594360"/>
           </a:xfrm>
           <a:prstGeom prst="line">
@@ -2074,8 +2074,8 @@
         </p:nvSpPr>
         <p:spPr>
           <a:xfrm>
-            <a:off x="10155885" y="2028952"/>
-            <a:ext cx="792480" cy="462280"/>
+            <a:off x="10023805" y="1940052"/>
+            <a:ext cx="1097280" cy="640080"/>
           </a:xfrm>
           <a:prstGeom prst="rect">
             <a:avLst/>
@@ -2091,9 +2091,9 @@
               <a:buNone/>
             </a:pPr>
             <a:r>
-              <a:rPr lang="en-US" sz="2600" b="1" dirty="0">
-                <a:solidFill>
-                  <a:srgbClr val="8A8A8A"/>
+              <a:rPr lang="en-US" sz="3600" b="1" dirty="0">
+                <a:solidFill>
+                  <a:srgbClr val="BBBBBB"/>
                 </a:solidFill>
                 <a:latin typeface="Arial" pitchFamily="34" charset="0"/>
                 <a:ea typeface="Arial" pitchFamily="34" charset="-122"/>
@@ -2101,7 +2101,7 @@
               </a:rPr>
               <a:t>×2</a:t>
             </a:r>
-            <a:endParaRPr lang="en-US" sz="2600" dirty="0"/>
+            <a:endParaRPr lang="en-US" sz="3600" dirty="0"/>
           </a:p>
         </p:txBody>
       </p:sp>
@@ -2386,7 +2386,7 @@
         </p:nvSpPr>
         <p:spPr>
           <a:xfrm>
-            <a:off x="2174291" y="1962912"/>
+            <a:off x="2273351" y="1962912"/>
             <a:ext cx="0" cy="594360"/>
           </a:xfrm>
           <a:prstGeom prst="line">
@@ -2409,7 +2409,7 @@
         </p:nvSpPr>
         <p:spPr>
           <a:xfrm>
-            <a:off x="10023805" y="1962912"/>
+            <a:off x="9924745" y="1962912"/>
             <a:ext cx="0" cy="594360"/>
           </a:xfrm>
           <a:prstGeom prst="line">
@@ -2432,8 +2432,8 @@
         </p:nvSpPr>
         <p:spPr>
           <a:xfrm>
-            <a:off x="10155885" y="2028952"/>
-            <a:ext cx="792480" cy="462280"/>
+            <a:off x="10023805" y="1940052"/>
+            <a:ext cx="1097280" cy="640080"/>
           </a:xfrm>
           <a:prstGeom prst="rect">
             <a:avLst/>
@@ -2449,9 +2449,9 @@
               <a:buNone/>
             </a:pPr>
             <a:r>
-              <a:rPr lang="en-US" sz="2600" b="1" dirty="0">
-                <a:solidFill>
-                  <a:srgbClr val="8A8A8A"/>
+              <a:rPr lang="en-US" sz="3600" b="1" dirty="0">
+                <a:solidFill>
+                  <a:srgbClr val="BBBBBB"/>
                 </a:solidFill>
                 <a:latin typeface="Arial" pitchFamily="34" charset="0"/>
                 <a:ea typeface="Arial" pitchFamily="34" charset="-122"/>
@@ -2459,7 +2459,7 @@
               </a:rPr>
               <a:t>×2</a:t>
             </a:r>
-            <a:endParaRPr lang="en-US" sz="2600" dirty="0"/>
+            <a:endParaRPr lang="en-US" sz="3600" dirty="0"/>
           </a:p>
         </p:txBody>
       </p:sp>
@@ -2744,7 +2744,7 @@
         </p:nvSpPr>
         <p:spPr>
           <a:xfrm>
-            <a:off x="2174291" y="1962912"/>
+            <a:off x="2273351" y="1962912"/>
             <a:ext cx="0" cy="594360"/>
           </a:xfrm>
           <a:prstGeom prst="line">
@@ -2767,7 +2767,7 @@
         </p:nvSpPr>
         <p:spPr>
           <a:xfrm>
-            <a:off x="10023805" y="1962912"/>
+            <a:off x="9924745" y="1962912"/>
             <a:ext cx="0" cy="594360"/>
           </a:xfrm>
           <a:prstGeom prst="line">
@@ -2790,8 +2790,8 @@
         </p:nvSpPr>
         <p:spPr>
           <a:xfrm>
-            <a:off x="10155885" y="2028952"/>
-            <a:ext cx="792480" cy="462280"/>
+            <a:off x="10023805" y="1940052"/>
+            <a:ext cx="1097280" cy="640080"/>
           </a:xfrm>
           <a:prstGeom prst="rect">
             <a:avLst/>
@@ -2807,9 +2807,9 @@
               <a:buNone/>
             </a:pPr>
             <a:r>
-              <a:rPr lang="en-US" sz="2600" b="1" dirty="0">
-                <a:solidFill>
-                  <a:srgbClr val="8A8A8A"/>
+              <a:rPr lang="en-US" sz="3600" b="1" dirty="0">
+                <a:solidFill>
+                  <a:srgbClr val="BBBBBB"/>
                 </a:solidFill>
                 <a:latin typeface="Arial" pitchFamily="34" charset="0"/>
                 <a:ea typeface="Arial" pitchFamily="34" charset="-122"/>
@@ -2817,7 +2817,7 @@
               </a:rPr>
               <a:t>×2</a:t>
             </a:r>
-            <a:endParaRPr lang="en-US" sz="2600" dirty="0"/>
+            <a:endParaRPr lang="en-US" sz="3600" dirty="0"/>
           </a:p>
         </p:txBody>
       </p:sp>
@@ -3085,7 +3085,7 @@
         </p:nvSpPr>
         <p:spPr>
           <a:xfrm>
-            <a:off x="2174291" y="1962912"/>
+            <a:off x="2273351" y="1962912"/>
             <a:ext cx="0" cy="594360"/>
           </a:xfrm>
           <a:prstGeom prst="line">
@@ -3108,7 +3108,7 @@
         </p:nvSpPr>
         <p:spPr>
           <a:xfrm>
-            <a:off x="10023805" y="1962912"/>
+            <a:off x="9924745" y="1962912"/>
             <a:ext cx="0" cy="594360"/>
           </a:xfrm>
           <a:prstGeom prst="line">
@@ -3131,8 +3131,8 @@
         </p:nvSpPr>
         <p:spPr>
           <a:xfrm>
-            <a:off x="10155885" y="2028952"/>
-            <a:ext cx="792480" cy="462280"/>
+            <a:off x="10023805" y="1940052"/>
+            <a:ext cx="1097280" cy="640080"/>
           </a:xfrm>
           <a:prstGeom prst="rect">
             <a:avLst/>
@@ -3148,9 +3148,9 @@
               <a:buNone/>
             </a:pPr>
             <a:r>
-              <a:rPr lang="en-US" sz="2600" b="1" dirty="0">
-                <a:solidFill>
-                  <a:srgbClr val="8A8A8A"/>
+              <a:rPr lang="en-US" sz="3600" b="1" dirty="0">
+                <a:solidFill>
+                  <a:srgbClr val="BBBBBB"/>
                 </a:solidFill>
                 <a:latin typeface="Arial" pitchFamily="34" charset="0"/>
                 <a:ea typeface="Arial" pitchFamily="34" charset="-122"/>
@@ -3158,7 +3158,7 @@
               </a:rPr>
               <a:t>×2</a:t>
             </a:r>
-            <a:endParaRPr lang="en-US" sz="2600" dirty="0"/>
+            <a:endParaRPr lang="en-US" sz="3600" dirty="0"/>
           </a:p>
         </p:txBody>
       </p:sp>

</xml_diff>